<commit_message>
completed up to and including slide 31
</commit_message>
<xml_diff>
--- a/145fa25_GreenfootCh4-Student-forHW4(1).pptx
+++ b/145fa25_GreenfootCh4-Student-forHW4(1).pptx
@@ -271,7 +271,7 @@
           <a:p>
             <a:fld id="{A4724E55-43F9-4BA1-98CF-42CA4B88A50E}" type="datetimeFigureOut">
               <a:rPr lang="en-US" smtClean="0"/>
-              <a:t>9/29/25</a:t>
+              <a:t>9/29/2025</a:t>
             </a:fld>
             <a:endParaRPr lang="en-US"/>
           </a:p>
@@ -436,7 +436,7 @@
           <a:p>
             <a:fld id="{6E7171C5-2FB7-874C-81B1-05567BC65CD3}" type="datetimeFigureOut">
               <a:rPr lang="en-US" smtClean="0"/>
-              <a:t>9/26/25</a:t>
+              <a:t>9/29/2025</a:t>
             </a:fld>
             <a:endParaRPr lang="en-US"/>
           </a:p>
@@ -1494,7 +1494,7 @@
           <a:p>
             <a:fld id="{0372C460-7F8A-3047-B0F0-A8926139445E}" type="datetimeFigureOut">
               <a:rPr lang="en-US" smtClean="0"/>
-              <a:t>9/26/25</a:t>
+              <a:t>9/29/2025</a:t>
             </a:fld>
             <a:endParaRPr lang="en-US"/>
           </a:p>
@@ -1662,7 +1662,7 @@
           <a:p>
             <a:fld id="{0372C460-7F8A-3047-B0F0-A8926139445E}" type="datetimeFigureOut">
               <a:rPr lang="en-US" smtClean="0"/>
-              <a:t>9/26/25</a:t>
+              <a:t>9/29/2025</a:t>
             </a:fld>
             <a:endParaRPr lang="en-US"/>
           </a:p>
@@ -1840,7 +1840,7 @@
           <a:p>
             <a:fld id="{0372C460-7F8A-3047-B0F0-A8926139445E}" type="datetimeFigureOut">
               <a:rPr lang="en-US" smtClean="0"/>
-              <a:t>9/26/25</a:t>
+              <a:t>9/29/2025</a:t>
             </a:fld>
             <a:endParaRPr lang="en-US"/>
           </a:p>
@@ -2008,7 +2008,7 @@
           <a:p>
             <a:fld id="{0372C460-7F8A-3047-B0F0-A8926139445E}" type="datetimeFigureOut">
               <a:rPr lang="en-US" smtClean="0"/>
-              <a:t>9/26/25</a:t>
+              <a:t>9/29/2025</a:t>
             </a:fld>
             <a:endParaRPr lang="en-US"/>
           </a:p>
@@ -2253,7 +2253,7 @@
           <a:p>
             <a:fld id="{0372C460-7F8A-3047-B0F0-A8926139445E}" type="datetimeFigureOut">
               <a:rPr lang="en-US" smtClean="0"/>
-              <a:t>9/26/25</a:t>
+              <a:t>9/29/2025</a:t>
             </a:fld>
             <a:endParaRPr lang="en-US"/>
           </a:p>
@@ -2538,7 +2538,7 @@
           <a:p>
             <a:fld id="{0372C460-7F8A-3047-B0F0-A8926139445E}" type="datetimeFigureOut">
               <a:rPr lang="en-US" smtClean="0"/>
-              <a:t>9/26/25</a:t>
+              <a:t>9/29/2025</a:t>
             </a:fld>
             <a:endParaRPr lang="en-US"/>
           </a:p>
@@ -2957,7 +2957,7 @@
           <a:p>
             <a:fld id="{0372C460-7F8A-3047-B0F0-A8926139445E}" type="datetimeFigureOut">
               <a:rPr lang="en-US" smtClean="0"/>
-              <a:t>9/26/25</a:t>
+              <a:t>9/29/2025</a:t>
             </a:fld>
             <a:endParaRPr lang="en-US"/>
           </a:p>
@@ -3074,7 +3074,7 @@
           <a:p>
             <a:fld id="{0372C460-7F8A-3047-B0F0-A8926139445E}" type="datetimeFigureOut">
               <a:rPr lang="en-US" smtClean="0"/>
-              <a:t>9/26/25</a:t>
+              <a:t>9/29/2025</a:t>
             </a:fld>
             <a:endParaRPr lang="en-US"/>
           </a:p>
@@ -3169,7 +3169,7 @@
           <a:p>
             <a:fld id="{0372C460-7F8A-3047-B0F0-A8926139445E}" type="datetimeFigureOut">
               <a:rPr lang="en-US" smtClean="0"/>
-              <a:t>9/26/25</a:t>
+              <a:t>9/29/2025</a:t>
             </a:fld>
             <a:endParaRPr lang="en-US"/>
           </a:p>
@@ -3444,7 +3444,7 @@
           <a:p>
             <a:fld id="{0372C460-7F8A-3047-B0F0-A8926139445E}" type="datetimeFigureOut">
               <a:rPr lang="en-US" smtClean="0"/>
-              <a:t>9/26/25</a:t>
+              <a:t>9/29/2025</a:t>
             </a:fld>
             <a:endParaRPr lang="en-US"/>
           </a:p>
@@ -3696,7 +3696,7 @@
           <a:p>
             <a:fld id="{0372C460-7F8A-3047-B0F0-A8926139445E}" type="datetimeFigureOut">
               <a:rPr lang="en-US" smtClean="0"/>
-              <a:t>9/26/25</a:t>
+              <a:t>9/29/2025</a:t>
             </a:fld>
             <a:endParaRPr lang="en-US"/>
           </a:p>
@@ -3907,7 +3907,7 @@
           <a:p>
             <a:fld id="{0372C460-7F8A-3047-B0F0-A8926139445E}" type="datetimeFigureOut">
               <a:rPr lang="en-US" smtClean="0"/>
-              <a:t>9/26/25</a:t>
+              <a:t>9/29/2025</a:t>
             </a:fld>
             <a:endParaRPr lang="en-US"/>
           </a:p>
@@ -8597,7 +8597,7 @@
                 <a:latin typeface="Calibri" panose="020F0502020204030204" pitchFamily="34" charset="0"/>
                 <a:cs typeface="Calibri" panose="020F0502020204030204" pitchFamily="34" charset="0"/>
               </a:rPr>
-              <a:t>**** ******</a:t>
+              <a:t> does not store the object</a:t>
             </a:r>
             <a:r>
               <a:rPr lang="en-US" sz="2400" b="1" dirty="0">
@@ -8893,21 +8893,20 @@
                   <a:srgbClr val="FFFF00"/>
                 </a:highlight>
               </a:rPr>
-              <a:t>******</a:t>
+              <a:t>reference</a:t>
             </a:r>
             <a:r>
               <a:rPr lang="en-US" dirty="0"/>
               <a:t> to the crab object to the </a:t>
             </a:r>
             <a:r>
-              <a:rPr lang="en-US" dirty="0">
+              <a:rPr lang="en-US" dirty="0" err="1">
                 <a:highlight>
                   <a:srgbClr val="FFFF00"/>
                 </a:highlight>
                 <a:latin typeface="Consolas" panose="020B0609020204030204" pitchFamily="49" charset="0"/>
-                <a:cs typeface="Consolas" panose="020B0609020204030204" pitchFamily="49" charset="0"/>
-              </a:rPr>
-              <a:t>*****</a:t>
+              </a:rPr>
+              <a:t>myCrab</a:t>
             </a:r>
             <a:r>
               <a:rPr lang="en-US" dirty="0"/>
@@ -9298,7 +9297,7 @@
                   <a:srgbClr val="FFFF00"/>
                 </a:highlight>
               </a:rPr>
-              <a:t>*****</a:t>
+              <a:t>reference</a:t>
             </a:r>
             <a:r>
               <a:rPr lang="en-US" sz="2800" i="1" dirty="0"/>
@@ -9871,7 +9870,7 @@
                   <a:srgbClr val="FFFF00"/>
                 </a:highlight>
               </a:rPr>
-              <a:t>**** *** *****</a:t>
+              <a:t>Save the World</a:t>
             </a:r>
           </a:p>
         </p:txBody>

</xml_diff>